<commit_message>
feat: add Huaita PPT generator and generated class report deck
</commit_message>
<xml_diff>
--- a/淮塔（淮海战役烈士纪念塔）课堂汇报.pptx
+++ b/淮塔（淮海战役烈士纪念塔）课堂汇报.pptx
@@ -3112,9 +3112,6 @@
           <a:lstStyle/>
           <a:p>
             <a:r>
-              <a:rPr>
-                <a:latin typeface="微软雅黑"/>
-              </a:rPr>
               <a:t>淮塔（淮海战役烈士纪念塔）</a:t>
             </a:r>
           </a:p>
@@ -3136,25 +3133,16 @@
           <a:lstStyle/>
           <a:p>
             <a:r>
-              <a:rPr>
-                <a:latin typeface="微软雅黑"/>
-              </a:rPr>
               <a:t>课堂汇报</a:t>
             </a:r>
           </a:p>
           <a:p>
             <a:r>
-              <a:rPr>
-                <a:latin typeface="微软雅黑"/>
-              </a:rPr>
               <a:t>汇报人：________</a:t>
             </a:r>
           </a:p>
           <a:p>
             <a:r>
-              <a:rPr>
-                <a:latin typeface="微软雅黑"/>
-              </a:rPr>
               <a:t>日期：________</a:t>
             </a:r>
           </a:p>
@@ -3194,9 +3182,6 @@
           <a:lstStyle/>
           <a:p>
             <a:r>
-              <a:rPr>
-                <a:latin typeface="微软雅黑"/>
-              </a:rPr>
               <a:t>淮塔是什么</a:t>
             </a:r>
           </a:p>
@@ -3219,36 +3204,24 @@
           <a:p>
             <a:pPr/>
             <a:r>
-              <a:rPr sz="2400">
-                <a:latin typeface="微软雅黑"/>
-              </a:rPr>
               <a:t>全称：淮海战役烈士纪念塔</a:t>
             </a:r>
           </a:p>
           <a:p>
             <a:pPr/>
             <a:r>
-              <a:rPr sz="2400">
-                <a:latin typeface="微软雅黑"/>
-              </a:rPr>
               <a:t>地点：江苏省徐州市</a:t>
             </a:r>
           </a:p>
           <a:p>
             <a:pPr/>
             <a:r>
-              <a:rPr sz="2400">
-                <a:latin typeface="微软雅黑"/>
-              </a:rPr>
               <a:t>定位：纪念先烈的革命纪念地与城市地标</a:t>
             </a:r>
           </a:p>
           <a:p>
             <a:pPr/>
             <a:r>
-              <a:rPr sz="2400">
-                <a:latin typeface="微软雅黑"/>
-              </a:rPr>
               <a:t>核心主题：铭记淮海战役历史与英雄精神</a:t>
             </a:r>
           </a:p>
@@ -3288,9 +3261,6 @@
           <a:lstStyle/>
           <a:p>
             <a:r>
-              <a:rPr>
-                <a:latin typeface="微软雅黑"/>
-              </a:rPr>
               <a:t>历史背景</a:t>
             </a:r>
           </a:p>
@@ -3313,36 +3283,24 @@
           <a:p>
             <a:pPr/>
             <a:r>
-              <a:rPr sz="2400">
-                <a:latin typeface="微软雅黑"/>
-              </a:rPr>
               <a:t>淮海战役是解放战争三大战役之一</a:t>
             </a:r>
           </a:p>
           <a:p>
             <a:pPr/>
             <a:r>
-              <a:rPr sz="2400">
-                <a:latin typeface="微软雅黑"/>
-              </a:rPr>
               <a:t>为缅怀在战役中牺牲的烈士而建设淮塔</a:t>
             </a:r>
           </a:p>
           <a:p>
             <a:pPr/>
             <a:r>
-              <a:rPr sz="2400">
-                <a:latin typeface="微软雅黑"/>
-              </a:rPr>
               <a:t>淮塔承载徐州与全国共同的红色记忆</a:t>
             </a:r>
           </a:p>
           <a:p>
             <a:pPr/>
             <a:r>
-              <a:rPr sz="2400">
-                <a:latin typeface="微软雅黑"/>
-              </a:rPr>
               <a:t>见证人民战争与军民团结的历史力量</a:t>
             </a:r>
           </a:p>
@@ -3382,9 +3340,6 @@
           <a:lstStyle/>
           <a:p>
             <a:r>
-              <a:rPr>
-                <a:latin typeface="微软雅黑"/>
-              </a:rPr>
               <a:t>建筑特色</a:t>
             </a:r>
           </a:p>
@@ -3407,36 +3362,24 @@
           <a:p>
             <a:pPr/>
             <a:r>
-              <a:rPr sz="2400">
-                <a:latin typeface="微软雅黑"/>
-              </a:rPr>
               <a:t>整体形态挺拔庄重，纪念性强</a:t>
             </a:r>
           </a:p>
           <a:p>
             <a:pPr/>
             <a:r>
-              <a:rPr sz="2400">
-                <a:latin typeface="微软雅黑"/>
-              </a:rPr>
               <a:t>塔体、基座、浮雕等构成完整纪念空间</a:t>
             </a:r>
           </a:p>
           <a:p>
             <a:pPr/>
             <a:r>
-              <a:rPr sz="2400">
-                <a:latin typeface="微软雅黑"/>
-              </a:rPr>
               <a:t>材质与线条强调肃穆、稳重、永恒</a:t>
             </a:r>
           </a:p>
           <a:p>
             <a:pPr/>
             <a:r>
-              <a:rPr sz="2400">
-                <a:latin typeface="微软雅黑"/>
-              </a:rPr>
               <a:t>视觉上体现“纪念丰碑”象征</a:t>
             </a:r>
           </a:p>
@@ -3476,9 +3419,6 @@
           <a:lstStyle/>
           <a:p>
             <a:r>
-              <a:rPr>
-                <a:latin typeface="微软雅黑"/>
-              </a:rPr>
               <a:t>纪念意义</a:t>
             </a:r>
           </a:p>
@@ -3501,36 +3441,24 @@
           <a:p>
             <a:pPr/>
             <a:r>
-              <a:rPr sz="2400">
-                <a:latin typeface="微软雅黑"/>
-              </a:rPr>
               <a:t>缅怀淮海战役英烈，致敬牺牲奉献</a:t>
             </a:r>
           </a:p>
           <a:p>
             <a:pPr/>
             <a:r>
-              <a:rPr sz="2400">
-                <a:latin typeface="微软雅黑"/>
-              </a:rPr>
               <a:t>强化“铭记历史、珍爱和平”的公共记忆</a:t>
             </a:r>
           </a:p>
           <a:p>
             <a:pPr/>
             <a:r>
-              <a:rPr sz="2400">
-                <a:latin typeface="微软雅黑"/>
-              </a:rPr>
               <a:t>弘扬革命精神与家国情怀</a:t>
             </a:r>
           </a:p>
           <a:p>
             <a:pPr/>
             <a:r>
-              <a:rPr sz="2400">
-                <a:latin typeface="微软雅黑"/>
-              </a:rPr>
               <a:t>激发新时代青年的责任意识</a:t>
             </a:r>
           </a:p>
@@ -3570,9 +3498,6 @@
           <a:lstStyle/>
           <a:p>
             <a:r>
-              <a:rPr>
-                <a:latin typeface="微软雅黑"/>
-              </a:rPr>
               <a:t>文化价值</a:t>
             </a:r>
           </a:p>
@@ -3595,36 +3520,24 @@
           <a:p>
             <a:pPr/>
             <a:r>
-              <a:rPr sz="2400">
-                <a:latin typeface="微软雅黑"/>
-              </a:rPr>
               <a:t>徐州红色文化的重要代表性符号</a:t>
             </a:r>
           </a:p>
           <a:p>
             <a:pPr/>
             <a:r>
-              <a:rPr sz="2400">
-                <a:latin typeface="微软雅黑"/>
-              </a:rPr>
               <a:t>连接城市历史文脉与集体记忆</a:t>
             </a:r>
           </a:p>
           <a:p>
             <a:pPr/>
             <a:r>
-              <a:rPr sz="2400">
-                <a:latin typeface="微软雅黑"/>
-              </a:rPr>
               <a:t>是爱国主义与革命传统教育的重要载体</a:t>
             </a:r>
           </a:p>
           <a:p>
             <a:pPr/>
             <a:r>
-              <a:rPr sz="2400">
-                <a:latin typeface="微软雅黑"/>
-              </a:rPr>
               <a:t>提升公众对历史文化遗产的认同感</a:t>
             </a:r>
           </a:p>
@@ -3664,9 +3577,6 @@
           <a:lstStyle/>
           <a:p>
             <a:r>
-              <a:rPr>
-                <a:latin typeface="微软雅黑"/>
-              </a:rPr>
               <a:t>实践意义</a:t>
             </a:r>
           </a:p>
@@ -3689,36 +3599,24 @@
           <a:p>
             <a:pPr/>
             <a:r>
-              <a:rPr sz="2400">
-                <a:latin typeface="微软雅黑"/>
-              </a:rPr>
               <a:t>适用于思政课、主题团日、研学实践</a:t>
             </a:r>
           </a:p>
           <a:p>
             <a:pPr/>
             <a:r>
-              <a:rPr sz="2400">
-                <a:latin typeface="微软雅黑"/>
-              </a:rPr>
               <a:t>帮助学生将历史知识转化为价值认同</a:t>
             </a:r>
           </a:p>
           <a:p>
             <a:pPr/>
             <a:r>
-              <a:rPr sz="2400">
-                <a:latin typeface="微软雅黑"/>
-              </a:rPr>
               <a:t>通过实地参观与讲解增强学习体验</a:t>
             </a:r>
           </a:p>
           <a:p>
             <a:pPr/>
             <a:r>
-              <a:rPr sz="2400">
-                <a:latin typeface="微软雅黑"/>
-              </a:rPr>
               <a:t>在纪念活动中发挥社会教育功能</a:t>
             </a:r>
           </a:p>
@@ -3758,9 +3656,6 @@
           <a:lstStyle/>
           <a:p>
             <a:r>
-              <a:rPr>
-                <a:latin typeface="微软雅黑"/>
-              </a:rPr>
               <a:t>总结</a:t>
             </a:r>
           </a:p>
@@ -3783,27 +3678,18 @@
           <a:p>
             <a:pPr/>
             <a:r>
-              <a:rPr sz="2400">
-                <a:latin typeface="微软雅黑"/>
-              </a:rPr>
               <a:t>淮塔不仅是纪念建筑，更是精神丰碑</a:t>
             </a:r>
           </a:p>
           <a:p>
             <a:pPr/>
             <a:r>
-              <a:rPr sz="2400">
-                <a:latin typeface="微软雅黑"/>
-              </a:rPr>
               <a:t>它记录历史、凝聚记忆、传承信念</a:t>
             </a:r>
           </a:p>
           <a:p>
             <a:pPr/>
             <a:r>
-              <a:rPr sz="2400">
-                <a:latin typeface="微软雅黑"/>
-              </a:rPr>
               <a:t>我们应铭记先烈、珍惜和平、勇担责任</a:t>
             </a:r>
           </a:p>
@@ -3843,9 +3729,6 @@
           <a:lstStyle/>
           <a:p>
             <a:r>
-              <a:rPr>
-                <a:latin typeface="微软雅黑"/>
-              </a:rPr>
               <a:t>结束</a:t>
             </a:r>
           </a:p>
@@ -3868,18 +3751,12 @@
           <a:p>
             <a:pPr/>
             <a:r>
-              <a:rPr sz="2400">
-                <a:latin typeface="微软雅黑"/>
-              </a:rPr>
               <a:t>感谢聆听</a:t>
             </a:r>
           </a:p>
           <a:p>
             <a:pPr/>
             <a:r>
-              <a:rPr sz="2400">
-                <a:latin typeface="微软雅黑"/>
-              </a:rPr>
               <a:t>欢迎交流</a:t>
             </a:r>
           </a:p>

</xml_diff>